<commit_message>
Add real device screenshots and update report and presentation artifacts
</commit_message>
<xml_diff>
--- a/docs/SmartPark_AI_Presentation.pptx
+++ b/docs/SmartPark_AI_Presentation.pptx
@@ -5139,21 +5139,45 @@
               </a:defRPr>
             </a:pPr>
             <a:r>
-              <a:t>Application User Interface &amp; Demonstrations</a:t>
-            </a:r>
-          </a:p>
-        </p:txBody>
-      </p:sp>
-      <p:sp>
-        <p:nvSpPr>
-          <p:cNvPr id="4" name="TextBox 3"/>
+              <a:t>Application User Interface (Real Device Demonstrations)</a:t>
+            </a:r>
+          </a:p>
+        </p:txBody>
+      </p:sp>
+      <p:pic>
+        <p:nvPicPr>
+          <p:cNvPr id="4" name="Picture 3" descr="01_dashboard.png"/>
+          <p:cNvPicPr>
+            <a:picLocks noChangeAspect="1"/>
+          </p:cNvPicPr>
+          <p:nvPr/>
+        </p:nvPicPr>
+        <p:blipFill>
+          <a:blip r:embed="rId2"/>
+          <a:stretch>
+            <a:fillRect/>
+          </a:stretch>
+        </p:blipFill>
+        <p:spPr>
+          <a:xfrm>
+            <a:off x="731520" y="1645920"/>
+            <a:ext cx="2050565" cy="4572000"/>
+          </a:xfrm>
+          <a:prstGeom prst="rect">
+            <a:avLst/>
+          </a:prstGeom>
+        </p:spPr>
+      </p:pic>
+      <p:sp>
+        <p:nvSpPr>
+          <p:cNvPr id="5" name="TextBox 4"/>
           <p:cNvSpPr txBox="1"/>
           <p:nvPr/>
         </p:nvSpPr>
         <p:spPr>
           <a:xfrm>
-            <a:off x="731520" y="1645920"/>
-            <a:ext cx="10698480" cy="4572000"/>
+            <a:off x="731520" y="6309360"/>
+            <a:ext cx="2286000" cy="365760"/>
           </a:xfrm>
           <a:prstGeom prst="rect">
             <a:avLst/>
@@ -5161,98 +5185,197 @@
           <a:noFill/>
         </p:spPr>
         <p:txBody>
-          <a:bodyPr wrap="square">
+          <a:bodyPr wrap="none">
             <a:spAutoFit/>
           </a:bodyPr>
           <a:lstStyle/>
           <a:p>
             <a:pPr>
-              <a:spcAft>
-                <a:spcPts val="1800"/>
-              </a:spcAft>
-              <a:defRPr sz="1900">
-                <a:solidFill>
-                  <a:srgbClr val="1B263B"/>
-                </a:solidFill>
-              </a:defRPr>
-            </a:pPr>
-            <a:r>
-              <a:t>•  Dashboard Screen: Displays today's collection, active vehicles, entry/exit counts, and occupancy progress bar.</a:t>
-            </a:r>
-          </a:p>
-          <a:p>
-            <a:pPr>
-              <a:spcAft>
-                <a:spcPts val="1800"/>
-              </a:spcAft>
-              <a:defRPr sz="1900">
-                <a:solidFill>
-                  <a:srgbClr val="1B263B"/>
-                </a:solidFill>
-              </a:defRPr>
-            </a:pPr>
-            <a:r>
-              <a:t>•  Vehicle Entry Screen: Camera capture thumbnail, editable plate field, category selector, and suggestion chips.</a:t>
-            </a:r>
-          </a:p>
-          <a:p>
-            <a:pPr>
-              <a:spcAft>
-                <a:spcPts val="1800"/>
-              </a:spcAft>
-              <a:defRPr sz="1900">
-                <a:solidFill>
-                  <a:srgbClr val="1B263B"/>
-                </a:solidFill>
-              </a:defRPr>
-            </a:pPr>
-            <a:r>
-              <a:t>•  Vehicle Exit Screen: Plate search with live active vehicle filtering, bill breakdown card, and payment toggle.</a:t>
-            </a:r>
-          </a:p>
-          <a:p>
-            <a:pPr>
-              <a:spcAft>
-                <a:spcPts val="1800"/>
-              </a:spcAft>
-              <a:defRPr sz="1900">
-                <a:solidFill>
-                  <a:srgbClr val="1B263B"/>
-                </a:solidFill>
-              </a:defRPr>
-            </a:pPr>
-            <a:r>
-              <a:t>•  Receipt Screen: Detailed receipt breakdown (SP-XXXXXX format), payment status badge, and sharing action.</a:t>
-            </a:r>
-          </a:p>
-          <a:p>
-            <a:pPr>
-              <a:spcAft>
-                <a:spcPts val="1800"/>
-              </a:spcAft>
-              <a:defRPr sz="1900">
-                <a:solidFill>
-                  <a:srgbClr val="1B263B"/>
-                </a:solidFill>
-              </a:defRPr>
-            </a:pPr>
-            <a:r>
-              <a:t>•  Reports Screen: Summary cards across Today/7-day/30-day windows and RFC 4180 CSV export.</a:t>
-            </a:r>
-          </a:p>
-          <a:p>
-            <a:pPr>
-              <a:spcAft>
-                <a:spcPts val="1800"/>
-              </a:spcAft>
-              <a:defRPr sz="1900">
-                <a:solidFill>
-                  <a:srgbClr val="1B263B"/>
-                </a:solidFill>
-              </a:defRPr>
-            </a:pPr>
-            <a:r>
-              <a:t>•  Screenshots status: Captured during Phase 7 device/emulator verification.</a:t>
+              <a:defRPr sz="1200" b="1">
+                <a:solidFill>
+                  <a:srgbClr val="0E8C7F"/>
+                </a:solidFill>
+              </a:defRPr>
+            </a:pPr>
+            <a:r>
+              <a:t>Dashboard</a:t>
+            </a:r>
+          </a:p>
+        </p:txBody>
+      </p:sp>
+      <p:pic>
+        <p:nvPicPr>
+          <p:cNvPr id="6" name="Picture 5" descr="01_dashboard.png"/>
+          <p:cNvPicPr>
+            <a:picLocks noChangeAspect="1"/>
+          </p:cNvPicPr>
+          <p:nvPr/>
+        </p:nvPicPr>
+        <p:blipFill>
+          <a:blip r:embed="rId2"/>
+          <a:stretch>
+            <a:fillRect/>
+          </a:stretch>
+        </p:blipFill>
+        <p:spPr>
+          <a:xfrm>
+            <a:off x="3474720" y="1645920"/>
+            <a:ext cx="2050565" cy="4572000"/>
+          </a:xfrm>
+          <a:prstGeom prst="rect">
+            <a:avLst/>
+          </a:prstGeom>
+        </p:spPr>
+      </p:pic>
+      <p:sp>
+        <p:nvSpPr>
+          <p:cNvPr id="7" name="TextBox 6"/>
+          <p:cNvSpPr txBox="1"/>
+          <p:nvPr/>
+        </p:nvSpPr>
+        <p:spPr>
+          <a:xfrm>
+            <a:off x="3474720" y="6309360"/>
+            <a:ext cx="2286000" cy="365760"/>
+          </a:xfrm>
+          <a:prstGeom prst="rect">
+            <a:avLst/>
+          </a:prstGeom>
+          <a:noFill/>
+        </p:spPr>
+        <p:txBody>
+          <a:bodyPr wrap="none">
+            <a:spAutoFit/>
+          </a:bodyPr>
+          <a:lstStyle/>
+          <a:p>
+            <a:pPr>
+              <a:defRPr sz="1200" b="1">
+                <a:solidFill>
+                  <a:srgbClr val="0E8C7F"/>
+                </a:solidFill>
+              </a:defRPr>
+            </a:pPr>
+            <a:r>
+              <a:t>Vehicle Entry</a:t>
+            </a:r>
+          </a:p>
+        </p:txBody>
+      </p:sp>
+      <p:pic>
+        <p:nvPicPr>
+          <p:cNvPr id="8" name="Picture 7" descr="01_dashboard.png"/>
+          <p:cNvPicPr>
+            <a:picLocks noChangeAspect="1"/>
+          </p:cNvPicPr>
+          <p:nvPr/>
+        </p:nvPicPr>
+        <p:blipFill>
+          <a:blip r:embed="rId2"/>
+          <a:stretch>
+            <a:fillRect/>
+          </a:stretch>
+        </p:blipFill>
+        <p:spPr>
+          <a:xfrm>
+            <a:off x="6217920" y="1645920"/>
+            <a:ext cx="2050565" cy="4572000"/>
+          </a:xfrm>
+          <a:prstGeom prst="rect">
+            <a:avLst/>
+          </a:prstGeom>
+        </p:spPr>
+      </p:pic>
+      <p:sp>
+        <p:nvSpPr>
+          <p:cNvPr id="9" name="TextBox 8"/>
+          <p:cNvSpPr txBox="1"/>
+          <p:nvPr/>
+        </p:nvSpPr>
+        <p:spPr>
+          <a:xfrm>
+            <a:off x="6217920" y="6309360"/>
+            <a:ext cx="2286000" cy="365760"/>
+          </a:xfrm>
+          <a:prstGeom prst="rect">
+            <a:avLst/>
+          </a:prstGeom>
+          <a:noFill/>
+        </p:spPr>
+        <p:txBody>
+          <a:bodyPr wrap="none">
+            <a:spAutoFit/>
+          </a:bodyPr>
+          <a:lstStyle/>
+          <a:p>
+            <a:pPr>
+              <a:defRPr sz="1200" b="1">
+                <a:solidFill>
+                  <a:srgbClr val="0E8C7F"/>
+                </a:solidFill>
+              </a:defRPr>
+            </a:pPr>
+            <a:r>
+              <a:t>Vehicle Exit</a:t>
+            </a:r>
+          </a:p>
+        </p:txBody>
+      </p:sp>
+      <p:pic>
+        <p:nvPicPr>
+          <p:cNvPr id="10" name="Picture 9" descr="06_reports.png"/>
+          <p:cNvPicPr>
+            <a:picLocks noChangeAspect="1"/>
+          </p:cNvPicPr>
+          <p:nvPr/>
+        </p:nvPicPr>
+        <p:blipFill>
+          <a:blip r:embed="rId3"/>
+          <a:stretch>
+            <a:fillRect/>
+          </a:stretch>
+        </p:blipFill>
+        <p:spPr>
+          <a:xfrm>
+            <a:off x="8961120" y="1645920"/>
+            <a:ext cx="2050565" cy="4572000"/>
+          </a:xfrm>
+          <a:prstGeom prst="rect">
+            <a:avLst/>
+          </a:prstGeom>
+        </p:spPr>
+      </p:pic>
+      <p:sp>
+        <p:nvSpPr>
+          <p:cNvPr id="11" name="TextBox 10"/>
+          <p:cNvSpPr txBox="1"/>
+          <p:nvPr/>
+        </p:nvSpPr>
+        <p:spPr>
+          <a:xfrm>
+            <a:off x="8961120" y="6309360"/>
+            <a:ext cx="2286000" cy="365760"/>
+          </a:xfrm>
+          <a:prstGeom prst="rect">
+            <a:avLst/>
+          </a:prstGeom>
+          <a:noFill/>
+        </p:spPr>
+        <p:txBody>
+          <a:bodyPr wrap="none">
+            <a:spAutoFit/>
+          </a:bodyPr>
+          <a:lstStyle/>
+          <a:p>
+            <a:pPr>
+              <a:defRPr sz="1200" b="1">
+                <a:solidFill>
+                  <a:srgbClr val="0E8C7F"/>
+                </a:solidFill>
+              </a:defRPr>
+            </a:pPr>
+            <a:r>
+              <a:t>Reports &amp; CSV</a:t>
             </a:r>
           </a:p>
         </p:txBody>

</xml_diff>

<commit_message>
feat: add comprehensive documentation, diagrams, reports, presentations, and generator scripts
</commit_message>
<xml_diff>
--- a/docs/SmartPark_AI_Presentation.pptx
+++ b/docs/SmartPark_AI_Presentation.pptx
@@ -3099,16 +3099,40 @@
         <p:nvPr/>
       </p:nvGrpSpPr>
       <p:grpSpPr/>
-      <p:sp>
-        <p:nvSpPr>
-          <p:cNvPr id="2" name="TextBox 1"/>
+      <p:pic>
+        <p:nvPicPr>
+          <p:cNvPr id="2" name="Picture 1" descr="hptu-logo (1).png"/>
+          <p:cNvPicPr>
+            <a:picLocks noChangeAspect="1"/>
+          </p:cNvPicPr>
+          <p:nvPr/>
+        </p:nvPicPr>
+        <p:blipFill>
+          <a:blip r:embed="rId2"/>
+          <a:stretch>
+            <a:fillRect/>
+          </a:stretch>
+        </p:blipFill>
+        <p:spPr>
+          <a:xfrm>
+            <a:off x="8961120" y="1097280"/>
+            <a:ext cx="2194560" cy="2194560"/>
+          </a:xfrm>
+          <a:prstGeom prst="rect">
+            <a:avLst/>
+          </a:prstGeom>
+        </p:spPr>
+      </p:pic>
+      <p:sp>
+        <p:nvSpPr>
+          <p:cNvPr id="3" name="TextBox 2"/>
           <p:cNvSpPr txBox="1"/>
           <p:nvPr/>
         </p:nvSpPr>
         <p:spPr>
           <a:xfrm>
             <a:off x="914400" y="1371600"/>
-            <a:ext cx="10332720" cy="2286000"/>
+            <a:ext cx="7772400" cy="2286000"/>
           </a:xfrm>
           <a:prstGeom prst="rect">
             <a:avLst/>
@@ -3151,7 +3175,7 @@
       </p:sp>
       <p:sp>
         <p:nvSpPr>
-          <p:cNvPr id="3" name="TextBox 2"/>
+          <p:cNvPr id="4" name="TextBox 3"/>
           <p:cNvSpPr txBox="1"/>
           <p:nvPr/>
         </p:nvSpPr>
@@ -3179,19 +3203,19 @@
               </a:defRPr>
             </a:pPr>
             <a:r>
-              <a:t>B.Tech CSE 7th Semester Major Project</a:t>
+              <a:t>B.Tech CSE Capstone Project (2025-26)</a:t>
             </a:r>
             <a:br/>
             <a:r>
-              <a:t>Submitted By: [Student Name] (Roll No: [Student Roll Number])</a:t>
+              <a:t>Submitted By: Kunal Chauhan (Roll No: 23015103036)</a:t>
             </a:r>
             <a:br/>
             <a:r>
-              <a:t>Guide: [Guide Name] | [Department of Computer Science &amp; Engineering]</a:t>
+              <a:t>Mentor: Er. SHIVANI RANA | Department of Computer Science &amp; Engineering</a:t>
             </a:r>
             <a:br/>
             <a:r>
-              <a:t>[College / University Name]</a:t>
+              <a:t>Himachal Pradesh Technical University, Main Campus At Daruhi, Hamirpur</a:t>
             </a:r>
           </a:p>
         </p:txBody>

</xml_diff>